<commit_message>
- Change panel titles from Spanish descriptions to Prometheus query expressions for clarity - Standardize legend formats to show metric description before app name - Add graph visualization properties (lines, fill, linewidth, nullPointMode) - Update presentation file with latest changes
</commit_message>
<xml_diff>
--- a/Presentation1.pptx
+++ b/Presentation1.pptx
@@ -7,6 +7,10 @@
   <p:sldIdLst>
     <p:sldId id="256" r:id="rId2"/>
     <p:sldId id="257" r:id="rId3"/>
+    <p:sldId id="258" r:id="rId4"/>
+    <p:sldId id="259" r:id="rId5"/>
+    <p:sldId id="261" r:id="rId6"/>
+    <p:sldId id="260" r:id="rId7"/>
   </p:sldIdLst>
   <p:sldSz cx="12192000" cy="6858000"/>
   <p:notesSz cx="6858000" cy="9144000"/>
@@ -105,6 +109,11 @@
       </a:defRPr>
     </a:lvl9pPr>
   </p:defaultTextStyle>
+  <p:extLst>
+    <p:ext uri="{EFAFB233-063F-42B5-8137-9DF3F51BA10A}">
+      <p15:sldGuideLst xmlns:p15="http://schemas.microsoft.com/office/powerpoint/2012/main"/>
+    </p:ext>
+  </p:extLst>
 </p:presentation>
 </file>
 
@@ -257,7 +266,7 @@
           <a:p>
             <a:fld id="{F7617E6C-B4C1-F64F-9F0E-38D55D0C6E24}" type="datetimeFigureOut">
               <a:rPr lang="en-GB" smtClean="0"/>
-              <a:t>08/04/2026</a:t>
+              <a:t>10/04/2026</a:t>
             </a:fld>
             <a:endParaRPr lang="en-GB"/>
           </a:p>
@@ -457,7 +466,7 @@
           <a:p>
             <a:fld id="{F7617E6C-B4C1-F64F-9F0E-38D55D0C6E24}" type="datetimeFigureOut">
               <a:rPr lang="en-GB" smtClean="0"/>
-              <a:t>08/04/2026</a:t>
+              <a:t>10/04/2026</a:t>
             </a:fld>
             <a:endParaRPr lang="en-GB"/>
           </a:p>
@@ -667,7 +676,7 @@
           <a:p>
             <a:fld id="{F7617E6C-B4C1-F64F-9F0E-38D55D0C6E24}" type="datetimeFigureOut">
               <a:rPr lang="en-GB" smtClean="0"/>
-              <a:t>08/04/2026</a:t>
+              <a:t>10/04/2026</a:t>
             </a:fld>
             <a:endParaRPr lang="en-GB"/>
           </a:p>
@@ -867,7 +876,7 @@
           <a:p>
             <a:fld id="{F7617E6C-B4C1-F64F-9F0E-38D55D0C6E24}" type="datetimeFigureOut">
               <a:rPr lang="en-GB" smtClean="0"/>
-              <a:t>08/04/2026</a:t>
+              <a:t>10/04/2026</a:t>
             </a:fld>
             <a:endParaRPr lang="en-GB"/>
           </a:p>
@@ -1143,7 +1152,7 @@
           <a:p>
             <a:fld id="{F7617E6C-B4C1-F64F-9F0E-38D55D0C6E24}" type="datetimeFigureOut">
               <a:rPr lang="en-GB" smtClean="0"/>
-              <a:t>08/04/2026</a:t>
+              <a:t>10/04/2026</a:t>
             </a:fld>
             <a:endParaRPr lang="en-GB"/>
           </a:p>
@@ -1411,7 +1420,7 @@
           <a:p>
             <a:fld id="{F7617E6C-B4C1-F64F-9F0E-38D55D0C6E24}" type="datetimeFigureOut">
               <a:rPr lang="en-GB" smtClean="0"/>
-              <a:t>08/04/2026</a:t>
+              <a:t>10/04/2026</a:t>
             </a:fld>
             <a:endParaRPr lang="en-GB"/>
           </a:p>
@@ -1826,7 +1835,7 @@
           <a:p>
             <a:fld id="{F7617E6C-B4C1-F64F-9F0E-38D55D0C6E24}" type="datetimeFigureOut">
               <a:rPr lang="en-GB" smtClean="0"/>
-              <a:t>08/04/2026</a:t>
+              <a:t>10/04/2026</a:t>
             </a:fld>
             <a:endParaRPr lang="en-GB"/>
           </a:p>
@@ -1968,7 +1977,7 @@
           <a:p>
             <a:fld id="{F7617E6C-B4C1-F64F-9F0E-38D55D0C6E24}" type="datetimeFigureOut">
               <a:rPr lang="en-GB" smtClean="0"/>
-              <a:t>08/04/2026</a:t>
+              <a:t>10/04/2026</a:t>
             </a:fld>
             <a:endParaRPr lang="en-GB"/>
           </a:p>
@@ -2081,7 +2090,7 @@
           <a:p>
             <a:fld id="{F7617E6C-B4C1-F64F-9F0E-38D55D0C6E24}" type="datetimeFigureOut">
               <a:rPr lang="en-GB" smtClean="0"/>
-              <a:t>08/04/2026</a:t>
+              <a:t>10/04/2026</a:t>
             </a:fld>
             <a:endParaRPr lang="en-GB"/>
           </a:p>
@@ -2394,7 +2403,7 @@
           <a:p>
             <a:fld id="{F7617E6C-B4C1-F64F-9F0E-38D55D0C6E24}" type="datetimeFigureOut">
               <a:rPr lang="en-GB" smtClean="0"/>
-              <a:t>08/04/2026</a:t>
+              <a:t>10/04/2026</a:t>
             </a:fld>
             <a:endParaRPr lang="en-GB"/>
           </a:p>
@@ -2683,7 +2692,7 @@
           <a:p>
             <a:fld id="{F7617E6C-B4C1-F64F-9F0E-38D55D0C6E24}" type="datetimeFigureOut">
               <a:rPr lang="en-GB" smtClean="0"/>
-              <a:t>08/04/2026</a:t>
+              <a:t>10/04/2026</a:t>
             </a:fld>
             <a:endParaRPr lang="en-GB"/>
           </a:p>
@@ -2926,7 +2935,7 @@
           <a:p>
             <a:fld id="{F7617E6C-B4C1-F64F-9F0E-38D55D0C6E24}" type="datetimeFigureOut">
               <a:rPr lang="en-GB" smtClean="0"/>
-              <a:t>08/04/2026</a:t>
+              <a:t>10/04/2026</a:t>
             </a:fld>
             <a:endParaRPr lang="en-GB"/>
           </a:p>
@@ -3551,6 +3560,1029 @@
 </p:sld>
 </file>
 
+<file path=ppt/slides/slide3.xml><?xml version="1.0" encoding="utf-8"?>
+<p:sld xmlns:a="http://schemas.openxmlformats.org/drawingml/2006/main" xmlns:r="http://schemas.openxmlformats.org/officeDocument/2006/relationships" xmlns:p="http://schemas.openxmlformats.org/presentationml/2006/main">
+  <p:cSld>
+    <p:spTree>
+      <p:nvGrpSpPr>
+        <p:cNvPr id="1" name=""/>
+        <p:cNvGrpSpPr/>
+        <p:nvPr/>
+      </p:nvGrpSpPr>
+      <p:grpSpPr>
+        <a:xfrm>
+          <a:off x="0" y="0"/>
+          <a:ext cx="0" cy="0"/>
+          <a:chOff x="0" y="0"/>
+          <a:chExt cx="0" cy="0"/>
+        </a:xfrm>
+      </p:grpSpPr>
+      <p:sp>
+        <p:nvSpPr>
+          <p:cNvPr id="20" name="Rectangle 19">
+            <a:extLst>
+              <a:ext uri="{FF2B5EF4-FFF2-40B4-BE49-F238E27FC236}">
+                <a16:creationId xmlns:a16="http://schemas.microsoft.com/office/drawing/2014/main" id="{A4C53363-07AA-9C4E-8276-2628BFA85A65}"/>
+              </a:ext>
+            </a:extLst>
+          </p:cNvPr>
+          <p:cNvSpPr/>
+          <p:nvPr/>
+        </p:nvSpPr>
+        <p:spPr>
+          <a:xfrm>
+            <a:off x="234778" y="89691"/>
+            <a:ext cx="13159946" cy="5339923"/>
+          </a:xfrm>
+          <a:prstGeom prst="rect">
+            <a:avLst/>
+          </a:prstGeom>
+        </p:spPr>
+        <p:txBody>
+          <a:bodyPr wrap="square">
+            <a:spAutoFit/>
+          </a:bodyPr>
+          <a:lstStyle/>
+          <a:p>
+            <a:r>
+              <a:rPr lang="es-ES" sz="1100" dirty="0">
+                <a:latin typeface="Menlo" panose="020B0609030804020204" pitchFamily="49" charset="0"/>
+              </a:rPr>
+              <a:t>Los cambios clave están en dos sitios del servicio</a:t>
+            </a:r>
+          </a:p>
+          <a:p>
+            <a:r>
+              <a:rPr lang="es-ES" sz="1100" dirty="0">
+                <a:latin typeface="Menlo" panose="020B0609030804020204" pitchFamily="49" charset="0"/>
+              </a:rPr>
+              <a:t>1. El </a:t>
+            </a:r>
+            <a:r>
+              <a:rPr lang="es-ES" sz="1100" dirty="0" err="1">
+                <a:latin typeface="Menlo" panose="020B0609030804020204" pitchFamily="49" charset="0"/>
+              </a:rPr>
+              <a:t>Executor</a:t>
+            </a:r>
+            <a:r>
+              <a:rPr lang="es-ES" sz="1100" dirty="0">
+                <a:latin typeface="Menlo" panose="020B0609030804020204" pitchFamily="49" charset="0"/>
+              </a:rPr>
+              <a:t> — la línea más importante de toda la demo</a:t>
+            </a:r>
+          </a:p>
+          <a:p>
+            <a:pPr lvl="1"/>
+            <a:r>
+              <a:rPr lang="es-ES" sz="1100" dirty="0" err="1">
+                <a:latin typeface="Menlo" panose="020B0609030804020204" pitchFamily="49" charset="0"/>
+              </a:rPr>
+              <a:t>Platform</a:t>
+            </a:r>
+            <a:r>
+              <a:rPr lang="es-ES" sz="1100" dirty="0">
+                <a:latin typeface="Menlo" panose="020B0609030804020204" pitchFamily="49" charset="0"/>
+              </a:rPr>
+              <a:t> </a:t>
+            </a:r>
+            <a:r>
+              <a:rPr lang="es-ES" sz="1100" dirty="0" err="1">
+                <a:latin typeface="Menlo" panose="020B0609030804020204" pitchFamily="49" charset="0"/>
+              </a:rPr>
+              <a:t>Threads</a:t>
+            </a:r>
+            <a:r>
+              <a:rPr lang="es-ES" sz="1100" dirty="0">
+                <a:latin typeface="Menlo" panose="020B0609030804020204" pitchFamily="49" charset="0"/>
+              </a:rPr>
+              <a:t> — PlatformThreadLoadGeneratorService.java:69</a:t>
+            </a:r>
+          </a:p>
+          <a:p>
+            <a:pPr lvl="1"/>
+            <a:br>
+              <a:rPr lang="es-ES" sz="1100" dirty="0">
+                <a:latin typeface="Menlo" panose="020B0609030804020204" pitchFamily="49" charset="0"/>
+              </a:rPr>
+            </a:br>
+            <a:r>
+              <a:rPr lang="es-ES" sz="1100" dirty="0" err="1">
+                <a:latin typeface="Menlo" panose="020B0609030804020204" pitchFamily="49" charset="0"/>
+              </a:rPr>
+              <a:t>ExecutorService</a:t>
+            </a:r>
+            <a:r>
+              <a:rPr lang="es-ES" sz="1100" dirty="0">
+                <a:latin typeface="Menlo" panose="020B0609030804020204" pitchFamily="49" charset="0"/>
+              </a:rPr>
+              <a:t> </a:t>
+            </a:r>
+            <a:r>
+              <a:rPr lang="es-ES" sz="1100" dirty="0" err="1">
+                <a:latin typeface="Menlo" panose="020B0609030804020204" pitchFamily="49" charset="0"/>
+              </a:rPr>
+              <a:t>executorService</a:t>
+            </a:r>
+            <a:r>
+              <a:rPr lang="es-ES" sz="1100" dirty="0">
+                <a:latin typeface="Menlo" panose="020B0609030804020204" pitchFamily="49" charset="0"/>
+              </a:rPr>
+              <a:t> = </a:t>
+            </a:r>
+            <a:r>
+              <a:rPr lang="es-ES" sz="1100" dirty="0" err="1">
+                <a:latin typeface="Menlo" panose="020B0609030804020204" pitchFamily="49" charset="0"/>
+              </a:rPr>
+              <a:t>Executors.newFixedThreadPool</a:t>
+            </a:r>
+            <a:r>
+              <a:rPr lang="es-ES" sz="1100" dirty="0">
+                <a:latin typeface="Menlo" panose="020B0609030804020204" pitchFamily="49" charset="0"/>
+              </a:rPr>
+              <a:t>(</a:t>
+            </a:r>
+            <a:r>
+              <a:rPr lang="es-ES" sz="1100" dirty="0" err="1">
+                <a:latin typeface="Menlo" panose="020B0609030804020204" pitchFamily="49" charset="0"/>
+              </a:rPr>
+              <a:t>request.getThreads</a:t>
+            </a:r>
+            <a:r>
+              <a:rPr lang="es-ES" sz="1100" dirty="0">
+                <a:latin typeface="Menlo" panose="020B0609030804020204" pitchFamily="49" charset="0"/>
+              </a:rPr>
+              <a:t>(), r -&gt; {</a:t>
+            </a:r>
+          </a:p>
+          <a:p>
+            <a:pPr lvl="1"/>
+            <a:r>
+              <a:rPr lang="es-ES" sz="1100" dirty="0" err="1">
+                <a:latin typeface="Menlo" panose="020B0609030804020204" pitchFamily="49" charset="0"/>
+              </a:rPr>
+              <a:t>Thread</a:t>
+            </a:r>
+            <a:r>
+              <a:rPr lang="es-ES" sz="1100" dirty="0">
+                <a:latin typeface="Menlo" panose="020B0609030804020204" pitchFamily="49" charset="0"/>
+              </a:rPr>
+              <a:t> </a:t>
+            </a:r>
+            <a:r>
+              <a:rPr lang="es-ES" sz="1100" dirty="0" err="1">
+                <a:latin typeface="Menlo" panose="020B0609030804020204" pitchFamily="49" charset="0"/>
+              </a:rPr>
+              <a:t>thread</a:t>
+            </a:r>
+            <a:r>
+              <a:rPr lang="es-ES" sz="1100" dirty="0">
+                <a:latin typeface="Menlo" panose="020B0609030804020204" pitchFamily="49" charset="0"/>
+              </a:rPr>
+              <a:t> = new </a:t>
+            </a:r>
+            <a:r>
+              <a:rPr lang="es-ES" sz="1100" dirty="0" err="1">
+                <a:latin typeface="Menlo" panose="020B0609030804020204" pitchFamily="49" charset="0"/>
+              </a:rPr>
+              <a:t>Thread</a:t>
+            </a:r>
+            <a:r>
+              <a:rPr lang="es-ES" sz="1100" dirty="0">
+                <a:latin typeface="Menlo" panose="020B0609030804020204" pitchFamily="49" charset="0"/>
+              </a:rPr>
+              <a:t>(r);</a:t>
+            </a:r>
+          </a:p>
+          <a:p>
+            <a:pPr lvl="1"/>
+            <a:r>
+              <a:rPr lang="es-ES" sz="1100" dirty="0" err="1">
+                <a:latin typeface="Menlo" panose="020B0609030804020204" pitchFamily="49" charset="0"/>
+              </a:rPr>
+              <a:t>thread.setName</a:t>
+            </a:r>
+            <a:r>
+              <a:rPr lang="es-ES" sz="1100" dirty="0">
+                <a:latin typeface="Menlo" panose="020B0609030804020204" pitchFamily="49" charset="0"/>
+              </a:rPr>
+              <a:t>("</a:t>
+            </a:r>
+            <a:r>
+              <a:rPr lang="es-ES" sz="1100" dirty="0" err="1">
+                <a:latin typeface="Menlo" panose="020B0609030804020204" pitchFamily="49" charset="0"/>
+              </a:rPr>
+              <a:t>platform-thread</a:t>
+            </a:r>
+            <a:r>
+              <a:rPr lang="es-ES" sz="1100" dirty="0">
+                <a:latin typeface="Menlo" panose="020B0609030804020204" pitchFamily="49" charset="0"/>
+              </a:rPr>
+              <a:t>-" + </a:t>
+            </a:r>
+            <a:r>
+              <a:rPr lang="es-ES" sz="1100" dirty="0" err="1">
+                <a:latin typeface="Menlo" panose="020B0609030804020204" pitchFamily="49" charset="0"/>
+              </a:rPr>
+              <a:t>System.currentTimeMillis</a:t>
+            </a:r>
+            <a:r>
+              <a:rPr lang="es-ES" sz="1100" dirty="0">
+                <a:latin typeface="Menlo" panose="020B0609030804020204" pitchFamily="49" charset="0"/>
+              </a:rPr>
+              <a:t>());</a:t>
+            </a:r>
+          </a:p>
+          <a:p>
+            <a:pPr lvl="1"/>
+            <a:r>
+              <a:rPr lang="es-ES" sz="1100" dirty="0" err="1">
+                <a:latin typeface="Menlo" panose="020B0609030804020204" pitchFamily="49" charset="0"/>
+              </a:rPr>
+              <a:t>return</a:t>
+            </a:r>
+            <a:r>
+              <a:rPr lang="es-ES" sz="1100" dirty="0">
+                <a:latin typeface="Menlo" panose="020B0609030804020204" pitchFamily="49" charset="0"/>
+              </a:rPr>
+              <a:t> </a:t>
+            </a:r>
+            <a:r>
+              <a:rPr lang="es-ES" sz="1100" dirty="0" err="1">
+                <a:latin typeface="Menlo" panose="020B0609030804020204" pitchFamily="49" charset="0"/>
+              </a:rPr>
+              <a:t>thread</a:t>
+            </a:r>
+            <a:r>
+              <a:rPr lang="es-ES" sz="1100" dirty="0">
+                <a:latin typeface="Menlo" panose="020B0609030804020204" pitchFamily="49" charset="0"/>
+              </a:rPr>
+              <a:t>;</a:t>
+            </a:r>
+          </a:p>
+          <a:p>
+            <a:pPr lvl="1"/>
+            <a:r>
+              <a:rPr lang="es-ES" sz="1100" dirty="0">
+                <a:latin typeface="Menlo" panose="020B0609030804020204" pitchFamily="49" charset="0"/>
+              </a:rPr>
+              <a:t>});</a:t>
+            </a:r>
+          </a:p>
+          <a:p>
+            <a:pPr lvl="1"/>
+            <a:r>
+              <a:rPr lang="es-ES" sz="1100" dirty="0">
+                <a:latin typeface="Menlo" panose="020B0609030804020204" pitchFamily="49" charset="0"/>
+              </a:rPr>
+              <a:t>Pool fijo. Si pides 1000 peticiones con 50 hilos, las 950 restantes esperan en cola.</a:t>
+            </a:r>
+          </a:p>
+          <a:p>
+            <a:pPr lvl="1"/>
+            <a:br>
+              <a:rPr lang="es-ES" sz="1100" dirty="0">
+                <a:latin typeface="Menlo" panose="020B0609030804020204" pitchFamily="49" charset="0"/>
+              </a:rPr>
+            </a:br>
+            <a:r>
+              <a:rPr lang="es-ES" sz="1100" dirty="0">
+                <a:latin typeface="Menlo" panose="020B0609030804020204" pitchFamily="49" charset="0"/>
+              </a:rPr>
+              <a:t>Virtual </a:t>
+            </a:r>
+            <a:r>
+              <a:rPr lang="es-ES" sz="1100" dirty="0" err="1">
+                <a:latin typeface="Menlo" panose="020B0609030804020204" pitchFamily="49" charset="0"/>
+              </a:rPr>
+              <a:t>Threads</a:t>
+            </a:r>
+            <a:r>
+              <a:rPr lang="es-ES" sz="1100" dirty="0">
+                <a:latin typeface="Menlo" panose="020B0609030804020204" pitchFamily="49" charset="0"/>
+              </a:rPr>
+              <a:t> — VirtualThreadLoadGeneratorService.java:69</a:t>
+            </a:r>
+          </a:p>
+          <a:p>
+            <a:pPr lvl="1"/>
+            <a:br>
+              <a:rPr lang="es-ES" sz="1100" dirty="0">
+                <a:latin typeface="Menlo" panose="020B0609030804020204" pitchFamily="49" charset="0"/>
+              </a:rPr>
+            </a:br>
+            <a:r>
+              <a:rPr lang="es-ES" sz="1100" dirty="0" err="1">
+                <a:latin typeface="Menlo" panose="020B0609030804020204" pitchFamily="49" charset="0"/>
+              </a:rPr>
+              <a:t>ExecutorService</a:t>
+            </a:r>
+            <a:r>
+              <a:rPr lang="es-ES" sz="1100" dirty="0">
+                <a:latin typeface="Menlo" panose="020B0609030804020204" pitchFamily="49" charset="0"/>
+              </a:rPr>
+              <a:t> </a:t>
+            </a:r>
+            <a:r>
+              <a:rPr lang="es-ES" sz="1100" dirty="0" err="1">
+                <a:latin typeface="Menlo" panose="020B0609030804020204" pitchFamily="49" charset="0"/>
+              </a:rPr>
+              <a:t>executorService</a:t>
+            </a:r>
+            <a:r>
+              <a:rPr lang="es-ES" sz="1100" dirty="0">
+                <a:latin typeface="Menlo" panose="020B0609030804020204" pitchFamily="49" charset="0"/>
+              </a:rPr>
+              <a:t> = </a:t>
+            </a:r>
+            <a:r>
+              <a:rPr lang="es-ES" sz="1100" dirty="0" err="1">
+                <a:latin typeface="Menlo" panose="020B0609030804020204" pitchFamily="49" charset="0"/>
+              </a:rPr>
+              <a:t>Executors.newVirtualThreadPerTaskExecutor</a:t>
+            </a:r>
+            <a:r>
+              <a:rPr lang="es-ES" sz="1100" dirty="0">
+                <a:latin typeface="Menlo" panose="020B0609030804020204" pitchFamily="49" charset="0"/>
+              </a:rPr>
+              <a:t>();</a:t>
+            </a:r>
+          </a:p>
+          <a:p>
+            <a:pPr lvl="1"/>
+            <a:r>
+              <a:rPr lang="es-ES" sz="1100" dirty="0">
+                <a:latin typeface="Menlo" panose="020B0609030804020204" pitchFamily="49" charset="0"/>
+              </a:rPr>
+              <a:t>Una sola línea distinta. Sin límite de hilos, sin pool. El resto del servicio es idéntico al </a:t>
+            </a:r>
+            <a:r>
+              <a:rPr lang="es-ES" sz="1100" dirty="0" err="1">
+                <a:latin typeface="Menlo" panose="020B0609030804020204" pitchFamily="49" charset="0"/>
+              </a:rPr>
+              <a:t>blocking</a:t>
+            </a:r>
+            <a:r>
+              <a:rPr lang="es-ES" sz="1100" dirty="0">
+                <a:latin typeface="Menlo" panose="020B0609030804020204" pitchFamily="49" charset="0"/>
+              </a:rPr>
+              <a:t>.</a:t>
+            </a:r>
+          </a:p>
+          <a:p>
+            <a:br>
+              <a:rPr lang="es-ES" sz="1100" dirty="0">
+                <a:latin typeface="Menlo" panose="020B0609030804020204" pitchFamily="49" charset="0"/>
+              </a:rPr>
+            </a:br>
+            <a:r>
+              <a:rPr lang="es-ES" sz="1100" dirty="0">
+                <a:latin typeface="Menlo" panose="020B0609030804020204" pitchFamily="49" charset="0"/>
+              </a:rPr>
+              <a:t>2. El modelo de programación — Reactive es el que rompe el molde</a:t>
+            </a:r>
+          </a:p>
+          <a:p>
+            <a:r>
+              <a:rPr lang="es-ES" sz="1100" dirty="0">
+                <a:latin typeface="Menlo" panose="020B0609030804020204" pitchFamily="49" charset="0"/>
+              </a:rPr>
+              <a:t>Reactive — ReactiveLoadGeneratorService.java:60</a:t>
+            </a:r>
+            <a:br>
+              <a:rPr lang="es-ES" sz="1100" dirty="0">
+                <a:latin typeface="Menlo" panose="020B0609030804020204" pitchFamily="49" charset="0"/>
+              </a:rPr>
+            </a:br>
+            <a:br>
+              <a:rPr lang="es-ES" sz="1100" dirty="0">
+                <a:latin typeface="Menlo" panose="020B0609030804020204" pitchFamily="49" charset="0"/>
+              </a:rPr>
+            </a:br>
+            <a:r>
+              <a:rPr lang="es-ES" sz="1100" dirty="0">
+                <a:latin typeface="Menlo" panose="020B0609030804020204" pitchFamily="49" charset="0"/>
+              </a:rPr>
+              <a:t>// Firma del método: devuelve Mono, no </a:t>
+            </a:r>
+            <a:r>
+              <a:rPr lang="es-ES" sz="1100" dirty="0" err="1">
+                <a:latin typeface="Menlo" panose="020B0609030804020204" pitchFamily="49" charset="0"/>
+              </a:rPr>
+              <a:t>LoadResponse</a:t>
+            </a:r>
+            <a:endParaRPr lang="es-ES" sz="1100" dirty="0">
+              <a:latin typeface="Menlo" panose="020B0609030804020204" pitchFamily="49" charset="0"/>
+            </a:endParaRPr>
+          </a:p>
+          <a:p>
+            <a:pPr lvl="1"/>
+            <a:r>
+              <a:rPr lang="es-ES" sz="1100" dirty="0" err="1">
+                <a:latin typeface="Menlo" panose="020B0609030804020204" pitchFamily="49" charset="0"/>
+              </a:rPr>
+              <a:t>public</a:t>
+            </a:r>
+            <a:r>
+              <a:rPr lang="es-ES" sz="1100" dirty="0">
+                <a:latin typeface="Menlo" panose="020B0609030804020204" pitchFamily="49" charset="0"/>
+              </a:rPr>
+              <a:t> Mono&lt;</a:t>
+            </a:r>
+            <a:r>
+              <a:rPr lang="es-ES" sz="1100" dirty="0" err="1">
+                <a:latin typeface="Menlo" panose="020B0609030804020204" pitchFamily="49" charset="0"/>
+              </a:rPr>
+              <a:t>LoadResponse</a:t>
+            </a:r>
+            <a:r>
+              <a:rPr lang="es-ES" sz="1100" dirty="0">
+                <a:latin typeface="Menlo" panose="020B0609030804020204" pitchFamily="49" charset="0"/>
+              </a:rPr>
+              <a:t>&gt; </a:t>
+            </a:r>
+            <a:r>
+              <a:rPr lang="es-ES" sz="1100" dirty="0" err="1">
+                <a:latin typeface="Menlo" panose="020B0609030804020204" pitchFamily="49" charset="0"/>
+              </a:rPr>
+              <a:t>executeLoad</a:t>
+            </a:r>
+            <a:r>
+              <a:rPr lang="es-ES" sz="1100" dirty="0">
+                <a:latin typeface="Menlo" panose="020B0609030804020204" pitchFamily="49" charset="0"/>
+              </a:rPr>
+              <a:t>(</a:t>
+            </a:r>
+            <a:r>
+              <a:rPr lang="es-ES" sz="1100" dirty="0" err="1">
+                <a:latin typeface="Menlo" panose="020B0609030804020204" pitchFamily="49" charset="0"/>
+              </a:rPr>
+              <a:t>LoadRequest</a:t>
+            </a:r>
+            <a:r>
+              <a:rPr lang="es-ES" sz="1100" dirty="0">
+                <a:latin typeface="Menlo" panose="020B0609030804020204" pitchFamily="49" charset="0"/>
+              </a:rPr>
+              <a:t> </a:t>
+            </a:r>
+            <a:r>
+              <a:rPr lang="es-ES" sz="1100" dirty="0" err="1">
+                <a:latin typeface="Menlo" panose="020B0609030804020204" pitchFamily="49" charset="0"/>
+              </a:rPr>
+              <a:t>request</a:t>
+            </a:r>
+            <a:r>
+              <a:rPr lang="es-ES" sz="1100" dirty="0">
+                <a:latin typeface="Menlo" panose="020B0609030804020204" pitchFamily="49" charset="0"/>
+              </a:rPr>
+              <a:t>) {</a:t>
+            </a:r>
+          </a:p>
+          <a:p>
+            <a:pPr lvl="1"/>
+            <a:br>
+              <a:rPr lang="es-ES" sz="1100" dirty="0">
+                <a:latin typeface="Menlo" panose="020B0609030804020204" pitchFamily="49" charset="0"/>
+              </a:rPr>
+            </a:br>
+            <a:r>
+              <a:rPr lang="es-ES" sz="1100" dirty="0">
+                <a:latin typeface="Menlo" panose="020B0609030804020204" pitchFamily="49" charset="0"/>
+              </a:rPr>
+              <a:t>// HTTP </a:t>
+            </a:r>
+            <a:r>
+              <a:rPr lang="es-ES" sz="1100" dirty="0" err="1">
+                <a:latin typeface="Menlo" panose="020B0609030804020204" pitchFamily="49" charset="0"/>
+              </a:rPr>
+              <a:t>client</a:t>
+            </a:r>
+            <a:r>
+              <a:rPr lang="es-ES" sz="1100" dirty="0">
+                <a:latin typeface="Menlo" panose="020B0609030804020204" pitchFamily="49" charset="0"/>
+              </a:rPr>
+              <a:t>: </a:t>
+            </a:r>
+            <a:r>
+              <a:rPr lang="es-ES" sz="1100" dirty="0" err="1">
+                <a:latin typeface="Menlo" panose="020B0609030804020204" pitchFamily="49" charset="0"/>
+              </a:rPr>
+              <a:t>WebClient</a:t>
+            </a:r>
+            <a:r>
+              <a:rPr lang="es-ES" sz="1100" dirty="0">
+                <a:latin typeface="Menlo" panose="020B0609030804020204" pitchFamily="49" charset="0"/>
+              </a:rPr>
+              <a:t> en vez de </a:t>
+            </a:r>
+            <a:r>
+              <a:rPr lang="es-ES" sz="1100" dirty="0" err="1">
+                <a:latin typeface="Menlo" panose="020B0609030804020204" pitchFamily="49" charset="0"/>
+              </a:rPr>
+              <a:t>RestTemplate</a:t>
+            </a:r>
+            <a:endParaRPr lang="es-ES" sz="1100" dirty="0">
+              <a:latin typeface="Menlo" panose="020B0609030804020204" pitchFamily="49" charset="0"/>
+            </a:endParaRPr>
+          </a:p>
+          <a:p>
+            <a:pPr lvl="1"/>
+            <a:r>
+              <a:rPr lang="es-ES" sz="1100" dirty="0" err="1">
+                <a:latin typeface="Menlo" panose="020B0609030804020204" pitchFamily="49" charset="0"/>
+              </a:rPr>
+              <a:t>private</a:t>
+            </a:r>
+            <a:r>
+              <a:rPr lang="es-ES" sz="1100" dirty="0">
+                <a:latin typeface="Menlo" panose="020B0609030804020204" pitchFamily="49" charset="0"/>
+              </a:rPr>
+              <a:t> final </a:t>
+            </a:r>
+            <a:r>
+              <a:rPr lang="es-ES" sz="1100" dirty="0" err="1">
+                <a:latin typeface="Menlo" panose="020B0609030804020204" pitchFamily="49" charset="0"/>
+              </a:rPr>
+              <a:t>WebClient</a:t>
+            </a:r>
+            <a:r>
+              <a:rPr lang="es-ES" sz="1100" dirty="0">
+                <a:latin typeface="Menlo" panose="020B0609030804020204" pitchFamily="49" charset="0"/>
+              </a:rPr>
+              <a:t> </a:t>
+            </a:r>
+            <a:r>
+              <a:rPr lang="es-ES" sz="1100" dirty="0" err="1">
+                <a:latin typeface="Menlo" panose="020B0609030804020204" pitchFamily="49" charset="0"/>
+              </a:rPr>
+              <a:t>webClient</a:t>
+            </a:r>
+            <a:r>
+              <a:rPr lang="es-ES" sz="1100" dirty="0">
+                <a:latin typeface="Menlo" panose="020B0609030804020204" pitchFamily="49" charset="0"/>
+              </a:rPr>
+              <a:t>;</a:t>
+            </a:r>
+          </a:p>
+          <a:p>
+            <a:pPr lvl="1"/>
+            <a:br>
+              <a:rPr lang="es-ES" sz="1100" dirty="0">
+                <a:latin typeface="Menlo" panose="020B0609030804020204" pitchFamily="49" charset="0"/>
+              </a:rPr>
+            </a:br>
+            <a:r>
+              <a:rPr lang="es-ES" sz="1100" dirty="0">
+                <a:latin typeface="Menlo" panose="020B0609030804020204" pitchFamily="49" charset="0"/>
+              </a:rPr>
+              <a:t>// En lugar de un </a:t>
+            </a:r>
+            <a:r>
+              <a:rPr lang="es-ES" sz="1100" dirty="0" err="1">
+                <a:latin typeface="Menlo" panose="020B0609030804020204" pitchFamily="49" charset="0"/>
+              </a:rPr>
+              <a:t>for</a:t>
+            </a:r>
+            <a:r>
+              <a:rPr lang="es-ES" sz="1100" dirty="0">
+                <a:latin typeface="Menlo" panose="020B0609030804020204" pitchFamily="49" charset="0"/>
+              </a:rPr>
+              <a:t> </a:t>
+            </a:r>
+            <a:r>
+              <a:rPr lang="es-ES" sz="1100" dirty="0" err="1">
+                <a:latin typeface="Menlo" panose="020B0609030804020204" pitchFamily="49" charset="0"/>
+              </a:rPr>
+              <a:t>loop</a:t>
+            </a:r>
+            <a:r>
+              <a:rPr lang="es-ES" sz="1100" dirty="0">
+                <a:latin typeface="Menlo" panose="020B0609030804020204" pitchFamily="49" charset="0"/>
+              </a:rPr>
+              <a:t> bloqueante, un pipeline reactivo</a:t>
+            </a:r>
+          </a:p>
+          <a:p>
+            <a:pPr lvl="1"/>
+            <a:r>
+              <a:rPr lang="es-ES" sz="1100" dirty="0" err="1">
+                <a:latin typeface="Menlo" panose="020B0609030804020204" pitchFamily="49" charset="0"/>
+              </a:rPr>
+              <a:t>return</a:t>
+            </a:r>
+            <a:r>
+              <a:rPr lang="es-ES" sz="1100" dirty="0">
+                <a:latin typeface="Menlo" panose="020B0609030804020204" pitchFamily="49" charset="0"/>
+              </a:rPr>
+              <a:t> </a:t>
+            </a:r>
+            <a:r>
+              <a:rPr lang="es-ES" sz="1100" dirty="0" err="1">
+                <a:latin typeface="Menlo" panose="020B0609030804020204" pitchFamily="49" charset="0"/>
+              </a:rPr>
+              <a:t>Flux.range</a:t>
+            </a:r>
+            <a:r>
+              <a:rPr lang="es-ES" sz="1100" dirty="0">
+                <a:latin typeface="Menlo" panose="020B0609030804020204" pitchFamily="49" charset="0"/>
+              </a:rPr>
+              <a:t>(0, </a:t>
+            </a:r>
+            <a:r>
+              <a:rPr lang="es-ES" sz="1100" dirty="0" err="1">
+                <a:latin typeface="Menlo" panose="020B0609030804020204" pitchFamily="49" charset="0"/>
+              </a:rPr>
+              <a:t>request.getRequests</a:t>
+            </a:r>
+            <a:r>
+              <a:rPr lang="es-ES" sz="1100" dirty="0">
+                <a:latin typeface="Menlo" panose="020B0609030804020204" pitchFamily="49" charset="0"/>
+              </a:rPr>
+              <a:t>())</a:t>
+            </a:r>
+          </a:p>
+          <a:p>
+            <a:pPr lvl="1"/>
+            <a:r>
+              <a:rPr lang="es-ES" sz="1100" dirty="0">
+                <a:latin typeface="Menlo" panose="020B0609030804020204" pitchFamily="49" charset="0"/>
+              </a:rPr>
+              <a:t>.</a:t>
+            </a:r>
+            <a:r>
+              <a:rPr lang="es-ES" sz="1100" dirty="0" err="1">
+                <a:latin typeface="Menlo" panose="020B0609030804020204" pitchFamily="49" charset="0"/>
+              </a:rPr>
+              <a:t>flatMap</a:t>
+            </a:r>
+            <a:r>
+              <a:rPr lang="es-ES" sz="1100" dirty="0">
+                <a:latin typeface="Menlo" panose="020B0609030804020204" pitchFamily="49" charset="0"/>
+              </a:rPr>
+              <a:t>(i -&gt; </a:t>
+            </a:r>
+            <a:r>
+              <a:rPr lang="es-ES" sz="1100" dirty="0" err="1">
+                <a:latin typeface="Menlo" panose="020B0609030804020204" pitchFamily="49" charset="0"/>
+              </a:rPr>
+              <a:t>executeReactiveRequest</a:t>
+            </a:r>
+            <a:r>
+              <a:rPr lang="es-ES" sz="1100" dirty="0">
+                <a:latin typeface="Menlo" panose="020B0609030804020204" pitchFamily="49" charset="0"/>
+              </a:rPr>
+              <a:t>(...), </a:t>
+            </a:r>
+            <a:r>
+              <a:rPr lang="es-ES" sz="1100" dirty="0" err="1">
+                <a:latin typeface="Menlo" panose="020B0609030804020204" pitchFamily="49" charset="0"/>
+              </a:rPr>
+              <a:t>request.getThreads</a:t>
+            </a:r>
+            <a:r>
+              <a:rPr lang="es-ES" sz="1100" dirty="0">
+                <a:latin typeface="Menlo" panose="020B0609030804020204" pitchFamily="49" charset="0"/>
+              </a:rPr>
+              <a:t>()) // concurrencia controlada</a:t>
+            </a:r>
+          </a:p>
+          <a:p>
+            <a:pPr lvl="1"/>
+            <a:r>
+              <a:rPr lang="es-ES" sz="1100" dirty="0">
+                <a:latin typeface="Menlo" panose="020B0609030804020204" pitchFamily="49" charset="0"/>
+              </a:rPr>
+              <a:t>.</a:t>
+            </a:r>
+            <a:r>
+              <a:rPr lang="es-ES" sz="1100" dirty="0" err="1">
+                <a:latin typeface="Menlo" panose="020B0609030804020204" pitchFamily="49" charset="0"/>
+              </a:rPr>
+              <a:t>collectList</a:t>
+            </a:r>
+            <a:r>
+              <a:rPr lang="es-ES" sz="1100" dirty="0">
+                <a:latin typeface="Menlo" panose="020B0609030804020204" pitchFamily="49" charset="0"/>
+              </a:rPr>
+              <a:t>()</a:t>
+            </a:r>
+          </a:p>
+          <a:p>
+            <a:pPr lvl="1"/>
+            <a:r>
+              <a:rPr lang="es-ES" sz="1100" dirty="0">
+                <a:latin typeface="Menlo" panose="020B0609030804020204" pitchFamily="49" charset="0"/>
+              </a:rPr>
+              <a:t>.</a:t>
+            </a:r>
+            <a:r>
+              <a:rPr lang="es-ES" sz="1100" dirty="0" err="1">
+                <a:latin typeface="Menlo" panose="020B0609030804020204" pitchFamily="49" charset="0"/>
+              </a:rPr>
+              <a:t>map</a:t>
+            </a:r>
+            <a:r>
+              <a:rPr lang="es-ES" sz="1100" dirty="0">
+                <a:latin typeface="Menlo" panose="020B0609030804020204" pitchFamily="49" charset="0"/>
+              </a:rPr>
+              <a:t>(</a:t>
+            </a:r>
+            <a:r>
+              <a:rPr lang="es-ES" sz="1100" dirty="0" err="1">
+                <a:latin typeface="Menlo" panose="020B0609030804020204" pitchFamily="49" charset="0"/>
+              </a:rPr>
+              <a:t>responseTimes</a:t>
+            </a:r>
+            <a:r>
+              <a:rPr lang="es-ES" sz="1100" dirty="0">
+                <a:latin typeface="Menlo" panose="020B0609030804020204" pitchFamily="49" charset="0"/>
+              </a:rPr>
+              <a:t> -&gt; { ... });</a:t>
+            </a:r>
+          </a:p>
+          <a:p>
+            <a:pPr lvl="1"/>
+            <a:r>
+              <a:rPr lang="es-ES" sz="1100" dirty="0">
+                <a:latin typeface="Menlo" panose="020B0609030804020204" pitchFamily="49" charset="0"/>
+              </a:rPr>
+              <a:t>}</a:t>
+            </a:r>
+          </a:p>
+        </p:txBody>
+      </p:sp>
+    </p:spTree>
+    <p:extLst>
+      <p:ext uri="{BB962C8B-B14F-4D97-AF65-F5344CB8AC3E}">
+        <p14:creationId xmlns:p14="http://schemas.microsoft.com/office/powerpoint/2010/main" val="3781947358"/>
+      </p:ext>
+    </p:extLst>
+  </p:cSld>
+  <p:clrMapOvr>
+    <a:masterClrMapping/>
+  </p:clrMapOvr>
+</p:sld>
+</file>
+
+<file path=ppt/slides/slide4.xml><?xml version="1.0" encoding="utf-8"?>
+<p:sld xmlns:a="http://schemas.openxmlformats.org/drawingml/2006/main" xmlns:r="http://schemas.openxmlformats.org/officeDocument/2006/relationships" xmlns:p="http://schemas.openxmlformats.org/presentationml/2006/main">
+  <p:cSld>
+    <p:spTree>
+      <p:nvGrpSpPr>
+        <p:cNvPr id="1" name=""/>
+        <p:cNvGrpSpPr/>
+        <p:nvPr/>
+      </p:nvGrpSpPr>
+      <p:grpSpPr>
+        <a:xfrm>
+          <a:off x="0" y="0"/>
+          <a:ext cx="0" cy="0"/>
+          <a:chOff x="0" y="0"/>
+          <a:chExt cx="0" cy="0"/>
+        </a:xfrm>
+      </p:grpSpPr>
+      <p:pic>
+        <p:nvPicPr>
+          <p:cNvPr id="4" name="Picture 3">
+            <a:extLst>
+              <a:ext uri="{FF2B5EF4-FFF2-40B4-BE49-F238E27FC236}">
+                <a16:creationId xmlns:a16="http://schemas.microsoft.com/office/drawing/2014/main" id="{93E96E42-6062-4A47-9C78-96947A71069D}"/>
+              </a:ext>
+            </a:extLst>
+          </p:cNvPr>
+          <p:cNvPicPr>
+            <a:picLocks noChangeAspect="1"/>
+          </p:cNvPicPr>
+          <p:nvPr/>
+        </p:nvPicPr>
+        <p:blipFill>
+          <a:blip r:embed="rId2"/>
+          <a:stretch>
+            <a:fillRect/>
+          </a:stretch>
+        </p:blipFill>
+        <p:spPr>
+          <a:xfrm>
+            <a:off x="222422" y="285078"/>
+            <a:ext cx="10919254" cy="3984343"/>
+          </a:xfrm>
+          <a:prstGeom prst="rect">
+            <a:avLst/>
+          </a:prstGeom>
+        </p:spPr>
+      </p:pic>
+    </p:spTree>
+    <p:extLst>
+      <p:ext uri="{BB962C8B-B14F-4D97-AF65-F5344CB8AC3E}">
+        <p14:creationId xmlns:p14="http://schemas.microsoft.com/office/powerpoint/2010/main" val="3397801922"/>
+      </p:ext>
+    </p:extLst>
+  </p:cSld>
+  <p:clrMapOvr>
+    <a:masterClrMapping/>
+  </p:clrMapOvr>
+</p:sld>
+</file>
+
+<file path=ppt/slides/slide5.xml><?xml version="1.0" encoding="utf-8"?>
+<p:sld xmlns:a="http://schemas.openxmlformats.org/drawingml/2006/main" xmlns:r="http://schemas.openxmlformats.org/officeDocument/2006/relationships" xmlns:p="http://schemas.openxmlformats.org/presentationml/2006/main">
+  <p:cSld>
+    <p:spTree>
+      <p:nvGrpSpPr>
+        <p:cNvPr id="1" name=""/>
+        <p:cNvGrpSpPr/>
+        <p:nvPr/>
+      </p:nvGrpSpPr>
+      <p:grpSpPr>
+        <a:xfrm>
+          <a:off x="0" y="0"/>
+          <a:ext cx="0" cy="0"/>
+          <a:chOff x="0" y="0"/>
+          <a:chExt cx="0" cy="0"/>
+        </a:xfrm>
+      </p:grpSpPr>
+      <p:pic>
+        <p:nvPicPr>
+          <p:cNvPr id="4" name="Picture 3">
+            <a:extLst>
+              <a:ext uri="{FF2B5EF4-FFF2-40B4-BE49-F238E27FC236}">
+                <a16:creationId xmlns:a16="http://schemas.microsoft.com/office/drawing/2014/main" id="{99D026DE-7B75-6446-B342-A1052F86CA87}"/>
+              </a:ext>
+            </a:extLst>
+          </p:cNvPr>
+          <p:cNvPicPr>
+            <a:picLocks noChangeAspect="1"/>
+          </p:cNvPicPr>
+          <p:nvPr/>
+        </p:nvPicPr>
+        <p:blipFill>
+          <a:blip r:embed="rId2"/>
+          <a:stretch>
+            <a:fillRect/>
+          </a:stretch>
+        </p:blipFill>
+        <p:spPr>
+          <a:xfrm>
+            <a:off x="469557" y="137339"/>
+            <a:ext cx="11438238" cy="2894012"/>
+          </a:xfrm>
+          <a:prstGeom prst="rect">
+            <a:avLst/>
+          </a:prstGeom>
+        </p:spPr>
+      </p:pic>
+      <p:pic>
+        <p:nvPicPr>
+          <p:cNvPr id="5" name="Picture 4">
+            <a:extLst>
+              <a:ext uri="{FF2B5EF4-FFF2-40B4-BE49-F238E27FC236}">
+                <a16:creationId xmlns:a16="http://schemas.microsoft.com/office/drawing/2014/main" id="{5932C01C-78DC-824D-9F78-4B58D1F95A9F}"/>
+              </a:ext>
+            </a:extLst>
+          </p:cNvPr>
+          <p:cNvPicPr>
+            <a:picLocks noChangeAspect="1"/>
+          </p:cNvPicPr>
+          <p:nvPr/>
+        </p:nvPicPr>
+        <p:blipFill>
+          <a:blip r:embed="rId3"/>
+          <a:stretch>
+            <a:fillRect/>
+          </a:stretch>
+        </p:blipFill>
+        <p:spPr>
+          <a:xfrm>
+            <a:off x="1121376" y="3153547"/>
+            <a:ext cx="10134600" cy="3467100"/>
+          </a:xfrm>
+          <a:prstGeom prst="rect">
+            <a:avLst/>
+          </a:prstGeom>
+        </p:spPr>
+      </p:pic>
+    </p:spTree>
+    <p:extLst>
+      <p:ext uri="{BB962C8B-B14F-4D97-AF65-F5344CB8AC3E}">
+        <p14:creationId xmlns:p14="http://schemas.microsoft.com/office/powerpoint/2010/main" val="1069101230"/>
+      </p:ext>
+    </p:extLst>
+  </p:cSld>
+  <p:clrMapOvr>
+    <a:masterClrMapping/>
+  </p:clrMapOvr>
+</p:sld>
+</file>
+
+<file path=ppt/slides/slide6.xml><?xml version="1.0" encoding="utf-8"?>
+<p:sld xmlns:a="http://schemas.openxmlformats.org/drawingml/2006/main" xmlns:r="http://schemas.openxmlformats.org/officeDocument/2006/relationships" xmlns:p="http://schemas.openxmlformats.org/presentationml/2006/main">
+  <p:cSld>
+    <p:spTree>
+      <p:nvGrpSpPr>
+        <p:cNvPr id="1" name=""/>
+        <p:cNvGrpSpPr/>
+        <p:nvPr/>
+      </p:nvGrpSpPr>
+      <p:grpSpPr>
+        <a:xfrm>
+          <a:off x="0" y="0"/>
+          <a:ext cx="0" cy="0"/>
+          <a:chOff x="0" y="0"/>
+          <a:chExt cx="0" cy="0"/>
+        </a:xfrm>
+      </p:grpSpPr>
+      <p:sp>
+        <p:nvSpPr>
+          <p:cNvPr id="4" name="Rectangle 3">
+            <a:extLst>
+              <a:ext uri="{FF2B5EF4-FFF2-40B4-BE49-F238E27FC236}">
+                <a16:creationId xmlns:a16="http://schemas.microsoft.com/office/drawing/2014/main" id="{AE06F4A9-5F41-B649-9DA2-D7350D0612A6}"/>
+              </a:ext>
+            </a:extLst>
+          </p:cNvPr>
+          <p:cNvSpPr/>
+          <p:nvPr/>
+        </p:nvSpPr>
+        <p:spPr>
+          <a:xfrm>
+            <a:off x="514864" y="315264"/>
+            <a:ext cx="8480854" cy="1200329"/>
+          </a:xfrm>
+          <a:prstGeom prst="rect">
+            <a:avLst/>
+          </a:prstGeom>
+        </p:spPr>
+        <p:txBody>
+          <a:bodyPr wrap="square">
+            <a:spAutoFit/>
+          </a:bodyPr>
+          <a:lstStyle/>
+          <a:p>
+            <a:pPr>
+              <a:buFont typeface="Arial" panose="020B0604020202020204" pitchFamily="34" charset="0"/>
+              <a:buChar char="•"/>
+            </a:pPr>
+            <a:r>
+              <a:rPr lang="es-ES" dirty="0">
+                <a:hlinkClick r:id="rId2" tooltip="https://wiki.openjdk.org/spaces/loom/pages/56525302/getting+started"/>
+              </a:rPr>
+              <a:t>https://wiki.openjdk.org/spaces/loom/pages/56525302/Getting+started</a:t>
+            </a:r>
+            <a:endParaRPr lang="es-ES" dirty="0"/>
+          </a:p>
+          <a:p>
+            <a:pPr>
+              <a:buFont typeface="Arial" panose="020B0604020202020204" pitchFamily="34" charset="0"/>
+              <a:buChar char="•"/>
+            </a:pPr>
+            <a:r>
+              <a:rPr lang="es-ES" dirty="0">
+                <a:hlinkClick r:id="rId3" tooltip="https://openjdk.org/jeps/425"/>
+              </a:rPr>
+              <a:t>https://openjdk.org/jeps/425</a:t>
+            </a:r>
+            <a:endParaRPr lang="es-ES" dirty="0"/>
+          </a:p>
+          <a:p>
+            <a:pPr>
+              <a:buFont typeface="Arial" panose="020B0604020202020204" pitchFamily="34" charset="0"/>
+              <a:buChar char="•"/>
+            </a:pPr>
+            <a:r>
+              <a:rPr lang="es-ES" dirty="0">
+                <a:hlinkClick r:id="rId4" tooltip="https://openjdk.org/jeps/444"/>
+              </a:rPr>
+              <a:t>https://openjdk.org/jeps/444</a:t>
+            </a:r>
+            <a:endParaRPr lang="es-ES" dirty="0"/>
+          </a:p>
+          <a:p>
+            <a:pPr>
+              <a:buFont typeface="Arial" panose="020B0604020202020204" pitchFamily="34" charset="0"/>
+              <a:buChar char="•"/>
+            </a:pPr>
+            <a:r>
+              <a:rPr lang="es-ES" dirty="0">
+                <a:hlinkClick r:id="rId5" tooltip="https://www.paradigmadigital.com/dev/ventajas-virtual-threads-java-21/"/>
+              </a:rPr>
+              <a:t>https://www.paradigmadigital.com/dev/ventajas-virtual-threads-java-21/</a:t>
+            </a:r>
+            <a:endParaRPr lang="es-ES" dirty="0"/>
+          </a:p>
+        </p:txBody>
+      </p:sp>
+    </p:spTree>
+    <p:extLst>
+      <p:ext uri="{BB962C8B-B14F-4D97-AF65-F5344CB8AC3E}">
+        <p14:creationId xmlns:p14="http://schemas.microsoft.com/office/powerpoint/2010/main" val="2050454444"/>
+      </p:ext>
+    </p:extLst>
+  </p:cSld>
+  <p:clrMapOvr>
+    <a:masterClrMapping/>
+  </p:clrMapOvr>
+</p:sld>
+</file>
+
 <file path=ppt/theme/theme1.xml><?xml version="1.0" encoding="utf-8"?>
 <a:theme xmlns:a="http://schemas.openxmlformats.org/drawingml/2006/main" name="Office Theme">
   <a:themeElements>

</xml_diff>